<commit_message>
Remove synthesized voice and provide a silent captioned demo
</commit_message>
<xml_diff>
--- a/SimToReal-Agent-Pitch.pptx
+++ b/SimToReal-Agent-Pitch.pptx
@@ -759,7 +759,7 @@
           </a:p>
           <a:p xmlns:a="http://schemas.openxmlformats.org/drawingml/2006/main">
             <a:r>
-              <a:t>Play demo-video.mp4 now. The video uses recorded outputs from our live AMD runs. Let the narration explain: AMD proposes candidates, the local simulation tests a successful placement, another candidate drops a part, and the unreachable task produces no approved candidate. Point out that the results shown here come from saved runs, while a fresh live request uses the current service and quota. If the presentation cannot switch windows, use the static result shown on this slide.</a:t>
+              <a:t>Play demo-video.mp4 now. The video uses recorded outputs from our live AMD runs. Explain in your own words: AMD proposes candidates, the local simulation tests a successful placement, another candidate drops a part, and the unreachable task produces no approved candidate. Point out that the results shown here come from saved runs, while a fresh live request uses the current service and quota. If the presentation cannot switch windows, use the static result shown on this slide.</a:t>
             </a:r>
           </a:p>
           <a:p xmlns:a="http://schemas.openxmlformats.org/drawingml/2006/main">
@@ -769,7 +769,7 @@
           </a:p>
           <a:p xmlns:a="http://schemas.openxmlformats.org/drawingml/2006/main">
             <a:r>
-              <a:t>Presenter action: play the 60-second demo-video.mp4 beside this deck, then return to slide 5. Video has captions and synthesized narration. Let it play without speaking over it.</a:t>
+              <a:t>Presenter action: play the 60-second demo-video.mp4 beside this deck, then return to slide 5. Video has captions and no audio. Let it play without speaking over it.</a:t>
             </a:r>
           </a:p>
           <a:p xmlns:a="http://schemas.openxmlformats.org/drawingml/2006/main">

</xml_diff>